<commit_message>
Add server smoke test to CI, QR codes on decks, demo-video recorder
- tools/smoke_test.py starts every app on a spare port from a temp copy and
  checks GET / and /api/health; CI now runs it on Linux and Windows
- CI actions bumped to checkout@v5 / setup-python@v6
- Closing slide of every deck carries a QR code to the project's code
  (generated by CertChain's from-scratch QR encoder via tools/qr_svg.py)
- tools/record_demos.js records a ~45 s captioned MP4 walkthrough per demo
  for the hackathon "demo link"
- README and STRATEGY document the smoke test, QA sweep and videos;
  decks and PDF report regenerated

Co-Authored-By: Claude Opus 5.5 <noreply@anthropic.com>
Claude-Session: https://claude.ai/code/session_01PH9emrYMr4WZEgQWhCQMKm
</commit_message>
<xml_diff>
--- a/decks/01-studypilot.pptx
+++ b/decks/01-studypilot.pptx
@@ -117,36 +117,36 @@
   <p:extLst>
     <p:ext uri="{521415D9-36F7-43E2-AB2F-B90AF26B5E84}">
       <p14:sectionLst xmlns:p14="http://schemas.microsoft.com/office/powerpoint/2010/main">
-        <p14:section name="Introduction" id="{ace6dd90-68d0-2924-450c-4267646563c6}">
+        <p14:section name="Introduction" id="{01d99193-7a74-b183-5399-3a0f06cdc3d5}">
           <p14:sldIdLst>
             <p14:sldId id="256"/>
           </p14:sldIdLst>
         </p14:section>
-        <p14:section name="Problem &amp; solution" id="{7285134a-f00d-d3c9-70cd-06952d9d9a3c}">
+        <p14:section name="Problem &amp; solution" id="{9cf86b61-4020-0d08-4f70-499feaa8b5d0}">
           <p14:sldIdLst>
             <p14:sldId id="257"/>
             <p14:sldId id="258"/>
           </p14:sldIdLst>
         </p14:section>
-        <p14:section name="Product" id="{bf8f82bc-20de-d4b8-4e48-7b39f6f110c7}">
+        <p14:section name="Product" id="{dd3ac2c1-d526-dd3e-f35d-815a5109ee6f}">
           <p14:sldIdLst>
             <p14:sldId id="259"/>
             <p14:sldId id="260"/>
             <p14:sldId id="261"/>
           </p14:sldIdLst>
         </p14:section>
-        <p14:section name="Why us" id="{ecee775a-82a0-00d9-b851-ce5d0580d009}">
+        <p14:section name="Why us" id="{a074c903-c020-f377-27d0-94e795ccf9d9}">
           <p14:sldIdLst>
             <p14:sldId id="262"/>
             <p14:sldId id="263"/>
           </p14:sldIdLst>
         </p14:section>
-        <p14:section name="Demo" id="{f71a06be-6ada-3c27-60de-61f487e91ab1}">
+        <p14:section name="Demo" id="{71216300-05d6-ed7a-c7b9-82d861b858c2}">
           <p14:sldIdLst>
             <p14:sldId id="264"/>
           </p14:sldIdLst>
         </p14:section>
-        <p14:section name="Roadmap" id="{2771e073-dd17-2c08-969b-da7e34c51bbd}">
+        <p14:section name="Roadmap" id="{a3170afa-ba1e-ad6e-4136-b13ff187e901}">
           <p14:sldIdLst>
             <p14:sldId id="265"/>
             <p14:sldId id="266"/>
@@ -2987,6 +2987,88 @@
               <a:t>Questions?</a:t>
             </a:r>
             <a:endParaRPr lang="en-US" sz="2600" dirty="0"/>
+          </a:p>
+        </p:txBody>
+      </p:sp>
+      <p:sp>
+        <p:nvSpPr>
+          <p:cNvPr id="6" name="QR card"/>
+          <p:cNvSpPr/>
+          <p:nvPr/>
+        </p:nvSpPr>
+        <p:spPr>
+          <a:xfrm>
+            <a:off x="9098280" y="1234440"/>
+            <a:ext cx="2514600" cy="2514600"/>
+          </a:xfrm>
+          <a:prstGeom prst="roundRect">
+            <a:avLst>
+              <a:gd name="adj" fmla="val 4364"/>
+            </a:avLst>
+          </a:prstGeom>
+          <a:solidFill>
+            <a:schemeClr val="bg1"/>
+          </a:solidFill>
+          <a:ln/>
+        </p:spPr>
+      </p:sp>
+      <p:pic>
+        <p:nvPicPr>
+          <p:cNvPr id="7" name="QR code" descr="QR code linking to the project's code">    </p:cNvPr>
+          <p:cNvPicPr>
+            <a:picLocks noChangeAspect="1"/>
+          </p:cNvPicPr>
+          <p:nvPr/>
+        </p:nvPicPr>
+        <p:blipFill>
+          <a:blip r:embed="rId1"/>
+          <a:stretch>
+            <a:fillRect/>
+          </a:stretch>
+        </p:blipFill>
+        <p:spPr>
+          <a:xfrm>
+            <a:off x="9189720" y="1325880"/>
+            <a:ext cx="2331720" cy="2331720"/>
+          </a:xfrm>
+          <a:prstGeom prst="rect">
+            <a:avLst/>
+          </a:prstGeom>
+        </p:spPr>
+      </p:pic>
+      <p:sp>
+        <p:nvSpPr>
+          <p:cNvPr id="8" name="QR caption"/>
+          <p:cNvSpPr txBox="1"/>
+          <p:nvPr/>
+        </p:nvSpPr>
+        <p:spPr>
+          <a:xfrm>
+            <a:off x="9098280" y="3767328"/>
+            <a:ext cx="2514600" cy="274320"/>
+          </a:xfrm>
+          <a:prstGeom prst="rect">
+            <a:avLst/>
+          </a:prstGeom>
+          <a:noFill/>
+          <a:ln/>
+        </p:spPr>
+        <p:txBody>
+          <a:bodyPr wrap="square" lIns="0" tIns="0" rIns="0" bIns="0" rtlCol="0" anchor="ctr"/>
+          <a:lstStyle/>
+          <a:p>
+            <a:pPr algn="ctr" indent="0" marL="0">
+              <a:buNone/>
+            </a:pPr>
+            <a:r>
+              <a:rPr lang="en-US" sz="1200" dirty="0">
+                <a:solidFill>
+                  <a:schemeClr val="accent6"/>
+                </a:solidFill>
+              </a:rPr>
+              <a:t>Scan for the code</a:t>
+            </a:r>
+            <a:endParaRPr lang="en-US" sz="1200" dirty="0"/>
           </a:p>
         </p:txBody>
       </p:sp>

</xml_diff>